<commit_message>
slide changes / fixes
</commit_message>
<xml_diff>
--- a/slides/03-3-Kruskals.pptx
+++ b/slides/03-3-Kruskals.pptx
@@ -14838,643 +14838,664 @@
           </a:p>
         </p:txBody>
       </p:sp>
-      <p:sp>
-        <p:nvSpPr>
-          <p:cNvPr id="2" name="Frame 1">
+      <p:grpSp>
+        <p:nvGrpSpPr>
+          <p:cNvPr id="4" name="Group 3">
             <a:extLst>
               <a:ext uri="{FF2B5EF4-FFF2-40B4-BE49-F238E27FC236}">
-                <a16:creationId xmlns:a16="http://schemas.microsoft.com/office/drawing/2014/main" id="{79DEB2DA-145A-724C-8355-D335FA8CF30D}"/>
+                <a16:creationId xmlns:a16="http://schemas.microsoft.com/office/drawing/2014/main" id="{29E28B66-DC77-AE8A-F5B3-0F3AE93E313B}"/>
               </a:ext>
             </a:extLst>
           </p:cNvPr>
-          <p:cNvSpPr/>
+          <p:cNvGrpSpPr/>
           <p:nvPr/>
-        </p:nvSpPr>
-        <p:spPr>
+        </p:nvGrpSpPr>
+        <p:grpSpPr>
           <a:xfrm>
-            <a:off x="3200407" y="4963506"/>
-            <a:ext cx="685801" cy="685800"/>
+            <a:off x="3200400" y="4963506"/>
+            <a:ext cx="5486413" cy="1371600"/>
+            <a:chOff x="3200400" y="4963506"/>
+            <a:chExt cx="5486413" cy="1371600"/>
           </a:xfrm>
-          <a:prstGeom prst="frame">
-            <a:avLst/>
-          </a:prstGeom>
-        </p:spPr>
-        <p:style>
-          <a:lnRef idx="2">
-            <a:schemeClr val="accent1">
-              <a:shade val="50000"/>
-            </a:schemeClr>
-          </a:lnRef>
-          <a:fillRef idx="1">
-            <a:schemeClr val="accent1"/>
-          </a:fillRef>
-          <a:effectRef idx="0">
-            <a:schemeClr val="accent1"/>
-          </a:effectRef>
-          <a:fontRef idx="minor">
-            <a:schemeClr val="lt1"/>
-          </a:fontRef>
-        </p:style>
-        <p:txBody>
-          <a:bodyPr rtlCol="0" anchor="ctr"/>
-          <a:lstStyle/>
-          <a:p>
-            <a:pPr algn="ctr"/>
-            <a:endParaRPr lang="en-US">
-              <a:solidFill>
-                <a:schemeClr val="tx1"/>
-              </a:solidFill>
-            </a:endParaRPr>
-          </a:p>
-        </p:txBody>
-      </p:sp>
-      <p:sp>
-        <p:nvSpPr>
-          <p:cNvPr id="7" name="Frame 6">
-            <a:extLst>
-              <a:ext uri="{FF2B5EF4-FFF2-40B4-BE49-F238E27FC236}">
-                <a16:creationId xmlns:a16="http://schemas.microsoft.com/office/drawing/2014/main" id="{A738F9C5-15B3-674C-A8C5-53FE8B35A3BC}"/>
-              </a:ext>
-            </a:extLst>
-          </p:cNvPr>
-          <p:cNvSpPr/>
-          <p:nvPr/>
-        </p:nvSpPr>
-        <p:spPr>
-          <a:xfrm>
-            <a:off x="3886208" y="4963506"/>
-            <a:ext cx="685801" cy="685800"/>
-          </a:xfrm>
-          <a:prstGeom prst="frame">
-            <a:avLst/>
-          </a:prstGeom>
-        </p:spPr>
-        <p:style>
-          <a:lnRef idx="2">
-            <a:schemeClr val="accent1">
-              <a:shade val="50000"/>
-            </a:schemeClr>
-          </a:lnRef>
-          <a:fillRef idx="1">
-            <a:schemeClr val="accent1"/>
-          </a:fillRef>
-          <a:effectRef idx="0">
-            <a:schemeClr val="accent1"/>
-          </a:effectRef>
-          <a:fontRef idx="minor">
-            <a:schemeClr val="lt1"/>
-          </a:fontRef>
-        </p:style>
-        <p:txBody>
-          <a:bodyPr rtlCol="0" anchor="ctr"/>
-          <a:lstStyle/>
-          <a:p>
-            <a:pPr algn="ctr"/>
-            <a:endParaRPr lang="en-US">
-              <a:solidFill>
-                <a:schemeClr val="tx1"/>
-              </a:solidFill>
-            </a:endParaRPr>
-          </a:p>
-        </p:txBody>
-      </p:sp>
-      <p:sp>
-        <p:nvSpPr>
-          <p:cNvPr id="8" name="Frame 7">
-            <a:extLst>
-              <a:ext uri="{FF2B5EF4-FFF2-40B4-BE49-F238E27FC236}">
-                <a16:creationId xmlns:a16="http://schemas.microsoft.com/office/drawing/2014/main" id="{54178AD7-7BE8-E640-96D3-9F562CCE40FA}"/>
-              </a:ext>
-            </a:extLst>
-          </p:cNvPr>
-          <p:cNvSpPr/>
-          <p:nvPr/>
-        </p:nvSpPr>
-        <p:spPr>
-          <a:xfrm>
-            <a:off x="4572009" y="4963506"/>
-            <a:ext cx="685801" cy="685800"/>
-          </a:xfrm>
-          <a:prstGeom prst="frame">
-            <a:avLst/>
-          </a:prstGeom>
-        </p:spPr>
-        <p:style>
-          <a:lnRef idx="2">
-            <a:schemeClr val="accent1">
-              <a:shade val="50000"/>
-            </a:schemeClr>
-          </a:lnRef>
-          <a:fillRef idx="1">
-            <a:schemeClr val="accent1"/>
-          </a:fillRef>
-          <a:effectRef idx="0">
-            <a:schemeClr val="accent1"/>
-          </a:effectRef>
-          <a:fontRef idx="minor">
-            <a:schemeClr val="lt1"/>
-          </a:fontRef>
-        </p:style>
-        <p:txBody>
-          <a:bodyPr rtlCol="0" anchor="ctr"/>
-          <a:lstStyle/>
-          <a:p>
-            <a:pPr algn="ctr"/>
-            <a:endParaRPr lang="en-US">
-              <a:solidFill>
-                <a:schemeClr val="tx1"/>
-              </a:solidFill>
-            </a:endParaRPr>
-          </a:p>
-        </p:txBody>
-      </p:sp>
-      <p:sp>
-        <p:nvSpPr>
-          <p:cNvPr id="9" name="Frame 8">
-            <a:extLst>
-              <a:ext uri="{FF2B5EF4-FFF2-40B4-BE49-F238E27FC236}">
-                <a16:creationId xmlns:a16="http://schemas.microsoft.com/office/drawing/2014/main" id="{A66DE4D0-8660-354C-B36C-DB3DB8FA359F}"/>
-              </a:ext>
-            </a:extLst>
-          </p:cNvPr>
-          <p:cNvSpPr/>
-          <p:nvPr/>
-        </p:nvSpPr>
-        <p:spPr>
-          <a:xfrm>
-            <a:off x="5257810" y="4963506"/>
-            <a:ext cx="685801" cy="685800"/>
-          </a:xfrm>
-          <a:prstGeom prst="frame">
-            <a:avLst/>
-          </a:prstGeom>
-        </p:spPr>
-        <p:style>
-          <a:lnRef idx="2">
-            <a:schemeClr val="accent1">
-              <a:shade val="50000"/>
-            </a:schemeClr>
-          </a:lnRef>
-          <a:fillRef idx="1">
-            <a:schemeClr val="accent1"/>
-          </a:fillRef>
-          <a:effectRef idx="0">
-            <a:schemeClr val="accent1"/>
-          </a:effectRef>
-          <a:fontRef idx="minor">
-            <a:schemeClr val="lt1"/>
-          </a:fontRef>
-        </p:style>
-        <p:txBody>
-          <a:bodyPr rtlCol="0" anchor="ctr"/>
-          <a:lstStyle/>
-          <a:p>
-            <a:pPr algn="ctr"/>
-            <a:endParaRPr lang="en-US">
-              <a:solidFill>
-                <a:schemeClr val="tx1"/>
-              </a:solidFill>
-            </a:endParaRPr>
-          </a:p>
-        </p:txBody>
-      </p:sp>
-      <p:sp>
-        <p:nvSpPr>
-          <p:cNvPr id="10" name="Frame 9">
-            <a:extLst>
-              <a:ext uri="{FF2B5EF4-FFF2-40B4-BE49-F238E27FC236}">
-                <a16:creationId xmlns:a16="http://schemas.microsoft.com/office/drawing/2014/main" id="{4C68D5E2-CC3F-BF46-B682-9EF1FE6E6E47}"/>
-              </a:ext>
-            </a:extLst>
-          </p:cNvPr>
-          <p:cNvSpPr/>
-          <p:nvPr/>
-        </p:nvSpPr>
-        <p:spPr>
-          <a:xfrm>
-            <a:off x="5943609" y="4963506"/>
-            <a:ext cx="685801" cy="685800"/>
-          </a:xfrm>
-          <a:prstGeom prst="frame">
-            <a:avLst/>
-          </a:prstGeom>
-        </p:spPr>
-        <p:style>
-          <a:lnRef idx="2">
-            <a:schemeClr val="accent1">
-              <a:shade val="50000"/>
-            </a:schemeClr>
-          </a:lnRef>
-          <a:fillRef idx="1">
-            <a:schemeClr val="accent1"/>
-          </a:fillRef>
-          <a:effectRef idx="0">
-            <a:schemeClr val="accent1"/>
-          </a:effectRef>
-          <a:fontRef idx="minor">
-            <a:schemeClr val="lt1"/>
-          </a:fontRef>
-        </p:style>
-        <p:txBody>
-          <a:bodyPr rtlCol="0" anchor="ctr"/>
-          <a:lstStyle/>
-          <a:p>
-            <a:pPr algn="ctr"/>
-            <a:endParaRPr lang="en-US">
-              <a:solidFill>
-                <a:schemeClr val="tx1"/>
-              </a:solidFill>
-            </a:endParaRPr>
-          </a:p>
-        </p:txBody>
-      </p:sp>
-      <p:sp>
-        <p:nvSpPr>
-          <p:cNvPr id="11" name="Frame 10">
-            <a:extLst>
-              <a:ext uri="{FF2B5EF4-FFF2-40B4-BE49-F238E27FC236}">
-                <a16:creationId xmlns:a16="http://schemas.microsoft.com/office/drawing/2014/main" id="{39883BB8-DF86-0B49-8080-6961C7119869}"/>
-              </a:ext>
-            </a:extLst>
-          </p:cNvPr>
-          <p:cNvSpPr/>
-          <p:nvPr/>
-        </p:nvSpPr>
-        <p:spPr>
-          <a:xfrm>
-            <a:off x="6629410" y="4963506"/>
-            <a:ext cx="685801" cy="685800"/>
-          </a:xfrm>
-          <a:prstGeom prst="frame">
-            <a:avLst/>
-          </a:prstGeom>
-        </p:spPr>
-        <p:style>
-          <a:lnRef idx="2">
-            <a:schemeClr val="accent1">
-              <a:shade val="50000"/>
-            </a:schemeClr>
-          </a:lnRef>
-          <a:fillRef idx="1">
-            <a:schemeClr val="accent1"/>
-          </a:fillRef>
-          <a:effectRef idx="0">
-            <a:schemeClr val="accent1"/>
-          </a:effectRef>
-          <a:fontRef idx="minor">
-            <a:schemeClr val="lt1"/>
-          </a:fontRef>
-        </p:style>
-        <p:txBody>
-          <a:bodyPr rtlCol="0" anchor="ctr"/>
-          <a:lstStyle/>
-          <a:p>
-            <a:pPr algn="ctr"/>
-            <a:endParaRPr lang="en-US">
-              <a:solidFill>
-                <a:schemeClr val="tx1"/>
-              </a:solidFill>
-            </a:endParaRPr>
-          </a:p>
-        </p:txBody>
-      </p:sp>
-      <p:sp>
-        <p:nvSpPr>
-          <p:cNvPr id="12" name="Frame 11">
-            <a:extLst>
-              <a:ext uri="{FF2B5EF4-FFF2-40B4-BE49-F238E27FC236}">
-                <a16:creationId xmlns:a16="http://schemas.microsoft.com/office/drawing/2014/main" id="{B45E09A4-D388-B34F-A618-EAD0DFE2A910}"/>
-              </a:ext>
-            </a:extLst>
-          </p:cNvPr>
-          <p:cNvSpPr/>
-          <p:nvPr/>
-        </p:nvSpPr>
-        <p:spPr>
-          <a:xfrm>
-            <a:off x="7315211" y="4963506"/>
-            <a:ext cx="685801" cy="685800"/>
-          </a:xfrm>
-          <a:prstGeom prst="frame">
-            <a:avLst/>
-          </a:prstGeom>
-        </p:spPr>
-        <p:style>
-          <a:lnRef idx="2">
-            <a:schemeClr val="accent1">
-              <a:shade val="50000"/>
-            </a:schemeClr>
-          </a:lnRef>
-          <a:fillRef idx="1">
-            <a:schemeClr val="accent1"/>
-          </a:fillRef>
-          <a:effectRef idx="0">
-            <a:schemeClr val="accent1"/>
-          </a:effectRef>
-          <a:fontRef idx="minor">
-            <a:schemeClr val="lt1"/>
-          </a:fontRef>
-        </p:style>
-        <p:txBody>
-          <a:bodyPr rtlCol="0" anchor="ctr"/>
-          <a:lstStyle/>
-          <a:p>
-            <a:pPr algn="ctr"/>
-            <a:endParaRPr lang="en-US">
-              <a:solidFill>
-                <a:schemeClr val="tx1"/>
-              </a:solidFill>
-            </a:endParaRPr>
-          </a:p>
-        </p:txBody>
-      </p:sp>
-      <p:sp>
-        <p:nvSpPr>
-          <p:cNvPr id="13" name="Frame 12">
-            <a:extLst>
-              <a:ext uri="{FF2B5EF4-FFF2-40B4-BE49-F238E27FC236}">
-                <a16:creationId xmlns:a16="http://schemas.microsoft.com/office/drawing/2014/main" id="{60A06877-D8CF-4544-8709-1E36A67C64DC}"/>
-              </a:ext>
-            </a:extLst>
-          </p:cNvPr>
-          <p:cNvSpPr/>
-          <p:nvPr/>
-        </p:nvSpPr>
-        <p:spPr>
-          <a:xfrm>
-            <a:off x="8001012" y="4963506"/>
-            <a:ext cx="685801" cy="685800"/>
-          </a:xfrm>
-          <a:prstGeom prst="frame">
-            <a:avLst/>
-          </a:prstGeom>
-        </p:spPr>
-        <p:style>
-          <a:lnRef idx="2">
-            <a:schemeClr val="accent1">
-              <a:shade val="50000"/>
-            </a:schemeClr>
-          </a:lnRef>
-          <a:fillRef idx="1">
-            <a:schemeClr val="accent1"/>
-          </a:fillRef>
-          <a:effectRef idx="0">
-            <a:schemeClr val="accent1"/>
-          </a:effectRef>
-          <a:fontRef idx="minor">
-            <a:schemeClr val="lt1"/>
-          </a:fontRef>
-        </p:style>
-        <p:txBody>
-          <a:bodyPr rtlCol="0" anchor="ctr"/>
-          <a:lstStyle/>
-          <a:p>
-            <a:pPr algn="ctr"/>
-            <a:endParaRPr lang="en-US">
-              <a:solidFill>
-                <a:schemeClr val="tx1"/>
-              </a:solidFill>
-            </a:endParaRPr>
-          </a:p>
-        </p:txBody>
-      </p:sp>
-      <p:sp>
-        <p:nvSpPr>
-          <p:cNvPr id="14" name="Rectangle 3">
-            <a:extLst>
-              <a:ext uri="{FF2B5EF4-FFF2-40B4-BE49-F238E27FC236}">
-                <a16:creationId xmlns:a16="http://schemas.microsoft.com/office/drawing/2014/main" id="{0E5A8076-DD7C-5C4F-8A0B-8BF37F39908F}"/>
-              </a:ext>
-            </a:extLst>
-          </p:cNvPr>
-          <p:cNvSpPr txBox="1">
-            <a:spLocks noChangeArrowheads="1"/>
-          </p:cNvSpPr>
-          <p:nvPr>
-            <p:custDataLst>
-              <p:tags r:id="rId3"/>
-            </p:custDataLst>
-          </p:nvPr>
-        </p:nvSpPr>
-        <p:spPr>
-          <a:xfrm>
-            <a:off x="3200400" y="5192106"/>
-            <a:ext cx="5486406" cy="1143000"/>
-          </a:xfrm>
-          <a:prstGeom prst="rect">
-            <a:avLst/>
-          </a:prstGeom>
-        </p:spPr>
-        <p:txBody>
-          <a:bodyPr vert="horz">
-            <a:normAutofit/>
-          </a:bodyPr>
-          <a:lstStyle>
-            <a:lvl1pPr marL="274320" indent="-274320" algn="just" rtl="0" eaLnBrk="1" latinLnBrk="0" hangingPunct="1">
-              <a:spcBef>
-                <a:spcPts val="600"/>
-              </a:spcBef>
-              <a:buClr>
-                <a:schemeClr val="accent1"/>
-              </a:buClr>
-              <a:buSzPct val="76000"/>
-              <a:buFont typeface="Wingdings 3"/>
-              <a:buChar char=""/>
-              <a:defRPr kumimoji="0" sz="2600" kern="1200">
+        </p:grpSpPr>
+        <p:sp>
+          <p:nvSpPr>
+            <p:cNvPr id="2" name="Frame 1">
+              <a:extLst>
+                <a:ext uri="{FF2B5EF4-FFF2-40B4-BE49-F238E27FC236}">
+                  <a16:creationId xmlns:a16="http://schemas.microsoft.com/office/drawing/2014/main" id="{79DEB2DA-145A-724C-8355-D335FA8CF30D}"/>
+                </a:ext>
+              </a:extLst>
+            </p:cNvPr>
+            <p:cNvSpPr/>
+            <p:nvPr/>
+          </p:nvSpPr>
+          <p:spPr>
+            <a:xfrm>
+              <a:off x="3200407" y="4963506"/>
+              <a:ext cx="685801" cy="685800"/>
+            </a:xfrm>
+            <a:prstGeom prst="frame">
+              <a:avLst/>
+            </a:prstGeom>
+          </p:spPr>
+          <p:style>
+            <a:lnRef idx="2">
+              <a:schemeClr val="accent1">
+                <a:shade val="50000"/>
+              </a:schemeClr>
+            </a:lnRef>
+            <a:fillRef idx="1">
+              <a:schemeClr val="accent1"/>
+            </a:fillRef>
+            <a:effectRef idx="0">
+              <a:schemeClr val="accent1"/>
+            </a:effectRef>
+            <a:fontRef idx="minor">
+              <a:schemeClr val="lt1"/>
+            </a:fontRef>
+          </p:style>
+          <p:txBody>
+            <a:bodyPr rtlCol="0" anchor="ctr"/>
+            <a:lstStyle/>
+            <a:p>
+              <a:pPr algn="ctr"/>
+              <a:endParaRPr lang="en-US">
                 <a:solidFill>
                   <a:schemeClr val="tx1"/>
                 </a:solidFill>
-                <a:latin typeface="+mn-lt"/>
-                <a:ea typeface="+mn-ea"/>
-                <a:cs typeface="+mn-cs"/>
-              </a:defRPr>
-            </a:lvl1pPr>
-            <a:lvl2pPr marL="548640" indent="-274320" algn="just" rtl="0" eaLnBrk="1" latinLnBrk="0" hangingPunct="1">
-              <a:spcBef>
-                <a:spcPts val="500"/>
-              </a:spcBef>
-              <a:buClr>
-                <a:schemeClr val="accent2"/>
-              </a:buClr>
-              <a:buSzPct val="76000"/>
-              <a:buFont typeface="Wingdings 3"/>
-              <a:buChar char=""/>
-              <a:defRPr kumimoji="0" sz="2300" kern="1200">
-                <a:solidFill>
-                  <a:schemeClr val="tx2"/>
-                </a:solidFill>
-                <a:latin typeface="+mn-lt"/>
-                <a:ea typeface="+mn-ea"/>
-                <a:cs typeface="+mn-cs"/>
-              </a:defRPr>
-            </a:lvl2pPr>
-            <a:lvl3pPr marL="822960" indent="-228600" algn="just" rtl="0" eaLnBrk="1" latinLnBrk="0" hangingPunct="1">
-              <a:spcBef>
-                <a:spcPts val="500"/>
-              </a:spcBef>
-              <a:buClr>
-                <a:schemeClr val="bg1">
-                  <a:shade val="50000"/>
-                </a:schemeClr>
-              </a:buClr>
-              <a:buSzPct val="76000"/>
-              <a:buFont typeface="Wingdings 3"/>
-              <a:buChar char=""/>
-              <a:defRPr kumimoji="0" sz="2000" kern="1200">
+              </a:endParaRPr>
+            </a:p>
+          </p:txBody>
+        </p:sp>
+        <p:sp>
+          <p:nvSpPr>
+            <p:cNvPr id="7" name="Frame 6">
+              <a:extLst>
+                <a:ext uri="{FF2B5EF4-FFF2-40B4-BE49-F238E27FC236}">
+                  <a16:creationId xmlns:a16="http://schemas.microsoft.com/office/drawing/2014/main" id="{A738F9C5-15B3-674C-A8C5-53FE8B35A3BC}"/>
+                </a:ext>
+              </a:extLst>
+            </p:cNvPr>
+            <p:cNvSpPr/>
+            <p:nvPr/>
+          </p:nvSpPr>
+          <p:spPr>
+            <a:xfrm>
+              <a:off x="3886208" y="4963506"/>
+              <a:ext cx="685801" cy="685800"/>
+            </a:xfrm>
+            <a:prstGeom prst="frame">
+              <a:avLst/>
+            </a:prstGeom>
+          </p:spPr>
+          <p:style>
+            <a:lnRef idx="2">
+              <a:schemeClr val="accent1">
+                <a:shade val="50000"/>
+              </a:schemeClr>
+            </a:lnRef>
+            <a:fillRef idx="1">
+              <a:schemeClr val="accent1"/>
+            </a:fillRef>
+            <a:effectRef idx="0">
+              <a:schemeClr val="accent1"/>
+            </a:effectRef>
+            <a:fontRef idx="minor">
+              <a:schemeClr val="lt1"/>
+            </a:fontRef>
+          </p:style>
+          <p:txBody>
+            <a:bodyPr rtlCol="0" anchor="ctr"/>
+            <a:lstStyle/>
+            <a:p>
+              <a:pPr algn="ctr"/>
+              <a:endParaRPr lang="en-US">
                 <a:solidFill>
                   <a:schemeClr val="tx1"/>
                 </a:solidFill>
-                <a:latin typeface="+mn-lt"/>
-                <a:ea typeface="+mn-ea"/>
-                <a:cs typeface="+mn-cs"/>
-              </a:defRPr>
-            </a:lvl3pPr>
-            <a:lvl4pPr marL="1097280" indent="-228600" algn="just" rtl="0" eaLnBrk="1" latinLnBrk="0" hangingPunct="1">
-              <a:spcBef>
-                <a:spcPts val="400"/>
-              </a:spcBef>
-              <a:buClr>
-                <a:schemeClr val="accent2">
-                  <a:shade val="75000"/>
-                </a:schemeClr>
-              </a:buClr>
-              <a:buSzPct val="70000"/>
-              <a:buFont typeface="Wingdings"/>
-              <a:buChar char=""/>
-              <a:defRPr kumimoji="0" sz="1800" kern="1200">
+              </a:endParaRPr>
+            </a:p>
+          </p:txBody>
+        </p:sp>
+        <p:sp>
+          <p:nvSpPr>
+            <p:cNvPr id="8" name="Frame 7">
+              <a:extLst>
+                <a:ext uri="{FF2B5EF4-FFF2-40B4-BE49-F238E27FC236}">
+                  <a16:creationId xmlns:a16="http://schemas.microsoft.com/office/drawing/2014/main" id="{54178AD7-7BE8-E640-96D3-9F562CCE40FA}"/>
+                </a:ext>
+              </a:extLst>
+            </p:cNvPr>
+            <p:cNvSpPr/>
+            <p:nvPr/>
+          </p:nvSpPr>
+          <p:spPr>
+            <a:xfrm>
+              <a:off x="4572009" y="4963506"/>
+              <a:ext cx="685801" cy="685800"/>
+            </a:xfrm>
+            <a:prstGeom prst="frame">
+              <a:avLst/>
+            </a:prstGeom>
+          </p:spPr>
+          <p:style>
+            <a:lnRef idx="2">
+              <a:schemeClr val="accent1">
+                <a:shade val="50000"/>
+              </a:schemeClr>
+            </a:lnRef>
+            <a:fillRef idx="1">
+              <a:schemeClr val="accent1"/>
+            </a:fillRef>
+            <a:effectRef idx="0">
+              <a:schemeClr val="accent1"/>
+            </a:effectRef>
+            <a:fontRef idx="minor">
+              <a:schemeClr val="lt1"/>
+            </a:fontRef>
+          </p:style>
+          <p:txBody>
+            <a:bodyPr rtlCol="0" anchor="ctr"/>
+            <a:lstStyle/>
+            <a:p>
+              <a:pPr algn="ctr"/>
+              <a:endParaRPr lang="en-US">
                 <a:solidFill>
                   <a:schemeClr val="tx1"/>
                 </a:solidFill>
-                <a:latin typeface="+mn-lt"/>
-                <a:ea typeface="+mn-ea"/>
-                <a:cs typeface="+mn-cs"/>
-              </a:defRPr>
-            </a:lvl4pPr>
-            <a:lvl5pPr marL="1371600" indent="-228600" algn="just" rtl="0" eaLnBrk="1" latinLnBrk="0" hangingPunct="1">
-              <a:spcBef>
-                <a:spcPts val="300"/>
-              </a:spcBef>
-              <a:buClr>
-                <a:schemeClr val="accent2"/>
-              </a:buClr>
-              <a:buSzPct val="70000"/>
-              <a:buFont typeface="Wingdings"/>
-              <a:buChar char=""/>
-              <a:defRPr kumimoji="0" sz="1600" kern="1200">
+              </a:endParaRPr>
+            </a:p>
+          </p:txBody>
+        </p:sp>
+        <p:sp>
+          <p:nvSpPr>
+            <p:cNvPr id="9" name="Frame 8">
+              <a:extLst>
+                <a:ext uri="{FF2B5EF4-FFF2-40B4-BE49-F238E27FC236}">
+                  <a16:creationId xmlns:a16="http://schemas.microsoft.com/office/drawing/2014/main" id="{A66DE4D0-8660-354C-B36C-DB3DB8FA359F}"/>
+                </a:ext>
+              </a:extLst>
+            </p:cNvPr>
+            <p:cNvSpPr/>
+            <p:nvPr/>
+          </p:nvSpPr>
+          <p:spPr>
+            <a:xfrm>
+              <a:off x="5257810" y="4963506"/>
+              <a:ext cx="685801" cy="685800"/>
+            </a:xfrm>
+            <a:prstGeom prst="frame">
+              <a:avLst/>
+            </a:prstGeom>
+          </p:spPr>
+          <p:style>
+            <a:lnRef idx="2">
+              <a:schemeClr val="accent1">
+                <a:shade val="50000"/>
+              </a:schemeClr>
+            </a:lnRef>
+            <a:fillRef idx="1">
+              <a:schemeClr val="accent1"/>
+            </a:fillRef>
+            <a:effectRef idx="0">
+              <a:schemeClr val="accent1"/>
+            </a:effectRef>
+            <a:fontRef idx="minor">
+              <a:schemeClr val="lt1"/>
+            </a:fontRef>
+          </p:style>
+          <p:txBody>
+            <a:bodyPr rtlCol="0" anchor="ctr"/>
+            <a:lstStyle/>
+            <a:p>
+              <a:pPr algn="ctr"/>
+              <a:endParaRPr lang="en-US">
                 <a:solidFill>
                   <a:schemeClr val="tx1"/>
                 </a:solidFill>
-                <a:latin typeface="+mn-lt"/>
-                <a:ea typeface="+mn-ea"/>
-                <a:cs typeface="+mn-cs"/>
-              </a:defRPr>
-            </a:lvl5pPr>
-            <a:lvl6pPr marL="1645920" indent="-182880" algn="l" rtl="0" eaLnBrk="1" latinLnBrk="0" hangingPunct="1">
-              <a:spcBef>
-                <a:spcPts val="300"/>
-              </a:spcBef>
-              <a:buClr>
-                <a:srgbClr val="9FB8CD">
-                  <a:shade val="75000"/>
-                </a:srgbClr>
-              </a:buClr>
-              <a:buSzPct val="75000"/>
-              <a:buFont typeface="Wingdings 3"/>
-              <a:buChar char=""/>
-              <a:defRPr kumimoji="0" lang="en-US" sz="1600" kern="1200" smtClean="0">
+              </a:endParaRPr>
+            </a:p>
+          </p:txBody>
+        </p:sp>
+        <p:sp>
+          <p:nvSpPr>
+            <p:cNvPr id="10" name="Frame 9">
+              <a:extLst>
+                <a:ext uri="{FF2B5EF4-FFF2-40B4-BE49-F238E27FC236}">
+                  <a16:creationId xmlns:a16="http://schemas.microsoft.com/office/drawing/2014/main" id="{4C68D5E2-CC3F-BF46-B682-9EF1FE6E6E47}"/>
+                </a:ext>
+              </a:extLst>
+            </p:cNvPr>
+            <p:cNvSpPr/>
+            <p:nvPr/>
+          </p:nvSpPr>
+          <p:spPr>
+            <a:xfrm>
+              <a:off x="5943609" y="4963506"/>
+              <a:ext cx="685801" cy="685800"/>
+            </a:xfrm>
+            <a:prstGeom prst="frame">
+              <a:avLst/>
+            </a:prstGeom>
+          </p:spPr>
+          <p:style>
+            <a:lnRef idx="2">
+              <a:schemeClr val="accent1">
+                <a:shade val="50000"/>
+              </a:schemeClr>
+            </a:lnRef>
+            <a:fillRef idx="1">
+              <a:schemeClr val="accent1"/>
+            </a:fillRef>
+            <a:effectRef idx="0">
+              <a:schemeClr val="accent1"/>
+            </a:effectRef>
+            <a:fontRef idx="minor">
+              <a:schemeClr val="lt1"/>
+            </a:fontRef>
+          </p:style>
+          <p:txBody>
+            <a:bodyPr rtlCol="0" anchor="ctr"/>
+            <a:lstStyle/>
+            <a:p>
+              <a:pPr algn="ctr"/>
+              <a:endParaRPr lang="en-US">
                 <a:solidFill>
                   <a:schemeClr val="tx1"/>
                 </a:solidFill>
-                <a:latin typeface="+mn-lt"/>
-                <a:ea typeface="+mn-ea"/>
-                <a:cs typeface="+mn-cs"/>
-              </a:defRPr>
-            </a:lvl6pPr>
-            <a:lvl7pPr marL="1828800" indent="-182880" algn="l" rtl="0" eaLnBrk="1" latinLnBrk="0" hangingPunct="1">
-              <a:spcBef>
-                <a:spcPts val="300"/>
-              </a:spcBef>
-              <a:buClr>
-                <a:srgbClr val="727CA3">
-                  <a:shade val="75000"/>
-                </a:srgbClr>
-              </a:buClr>
-              <a:buSzPct val="75000"/>
-              <a:buFont typeface="Wingdings 3"/>
-              <a:buChar char=""/>
-              <a:defRPr kumimoji="0" lang="en-US" sz="1400" kern="1200" smtClean="0">
+              </a:endParaRPr>
+            </a:p>
+          </p:txBody>
+        </p:sp>
+        <p:sp>
+          <p:nvSpPr>
+            <p:cNvPr id="11" name="Frame 10">
+              <a:extLst>
+                <a:ext uri="{FF2B5EF4-FFF2-40B4-BE49-F238E27FC236}">
+                  <a16:creationId xmlns:a16="http://schemas.microsoft.com/office/drawing/2014/main" id="{39883BB8-DF86-0B49-8080-6961C7119869}"/>
+                </a:ext>
+              </a:extLst>
+            </p:cNvPr>
+            <p:cNvSpPr/>
+            <p:nvPr/>
+          </p:nvSpPr>
+          <p:spPr>
+            <a:xfrm>
+              <a:off x="6629410" y="4963506"/>
+              <a:ext cx="685801" cy="685800"/>
+            </a:xfrm>
+            <a:prstGeom prst="frame">
+              <a:avLst/>
+            </a:prstGeom>
+          </p:spPr>
+          <p:style>
+            <a:lnRef idx="2">
+              <a:schemeClr val="accent1">
+                <a:shade val="50000"/>
+              </a:schemeClr>
+            </a:lnRef>
+            <a:fillRef idx="1">
+              <a:schemeClr val="accent1"/>
+            </a:fillRef>
+            <a:effectRef idx="0">
+              <a:schemeClr val="accent1"/>
+            </a:effectRef>
+            <a:fontRef idx="minor">
+              <a:schemeClr val="lt1"/>
+            </a:fontRef>
+          </p:style>
+          <p:txBody>
+            <a:bodyPr rtlCol="0" anchor="ctr"/>
+            <a:lstStyle/>
+            <a:p>
+              <a:pPr algn="ctr"/>
+              <a:endParaRPr lang="en-US">
                 <a:solidFill>
                   <a:schemeClr val="tx1"/>
                 </a:solidFill>
-                <a:latin typeface="+mn-lt"/>
-                <a:ea typeface="+mn-ea"/>
-                <a:cs typeface="+mn-cs"/>
-              </a:defRPr>
-            </a:lvl7pPr>
-            <a:lvl8pPr marL="2011680" indent="-182880" algn="l" rtl="0" eaLnBrk="1" latinLnBrk="0" hangingPunct="1">
-              <a:spcBef>
-                <a:spcPts val="300"/>
-              </a:spcBef>
-              <a:buClr>
-                <a:prstClr val="white">
-                  <a:shade val="50000"/>
-                </a:prstClr>
-              </a:buClr>
-              <a:buSzPct val="75000"/>
-              <a:buFont typeface="Wingdings 3"/>
-              <a:buChar char=""/>
-              <a:defRPr kumimoji="0" lang="en-US" sz="1400" kern="1200" smtClean="0">
+              </a:endParaRPr>
+            </a:p>
+          </p:txBody>
+        </p:sp>
+        <p:sp>
+          <p:nvSpPr>
+            <p:cNvPr id="12" name="Frame 11">
+              <a:extLst>
+                <a:ext uri="{FF2B5EF4-FFF2-40B4-BE49-F238E27FC236}">
+                  <a16:creationId xmlns:a16="http://schemas.microsoft.com/office/drawing/2014/main" id="{B45E09A4-D388-B34F-A618-EAD0DFE2A910}"/>
+                </a:ext>
+              </a:extLst>
+            </p:cNvPr>
+            <p:cNvSpPr/>
+            <p:nvPr/>
+          </p:nvSpPr>
+          <p:spPr>
+            <a:xfrm>
+              <a:off x="7315211" y="4963506"/>
+              <a:ext cx="685801" cy="685800"/>
+            </a:xfrm>
+            <a:prstGeom prst="frame">
+              <a:avLst/>
+            </a:prstGeom>
+          </p:spPr>
+          <p:style>
+            <a:lnRef idx="2">
+              <a:schemeClr val="accent1">
+                <a:shade val="50000"/>
+              </a:schemeClr>
+            </a:lnRef>
+            <a:fillRef idx="1">
+              <a:schemeClr val="accent1"/>
+            </a:fillRef>
+            <a:effectRef idx="0">
+              <a:schemeClr val="accent1"/>
+            </a:effectRef>
+            <a:fontRef idx="minor">
+              <a:schemeClr val="lt1"/>
+            </a:fontRef>
+          </p:style>
+          <p:txBody>
+            <a:bodyPr rtlCol="0" anchor="ctr"/>
+            <a:lstStyle/>
+            <a:p>
+              <a:pPr algn="ctr"/>
+              <a:endParaRPr lang="en-US">
                 <a:solidFill>
                   <a:schemeClr val="tx1"/>
                 </a:solidFill>
-                <a:latin typeface="+mn-lt"/>
-                <a:ea typeface="+mn-ea"/>
-                <a:cs typeface="+mn-cs"/>
-              </a:defRPr>
-            </a:lvl8pPr>
-            <a:lvl9pPr marL="2194560" indent="-182880" algn="l" rtl="0" eaLnBrk="1" latinLnBrk="0" hangingPunct="1">
-              <a:spcBef>
-                <a:spcPts val="300"/>
-              </a:spcBef>
-              <a:buClr>
-                <a:srgbClr val="9FB8CD"/>
-              </a:buClr>
-              <a:buSzPct val="75000"/>
-              <a:buFont typeface="Wingdings 3"/>
-              <a:buChar char=""/>
-              <a:defRPr kumimoji="0" lang="en-US" sz="1200" kern="1200" smtClean="0">
+              </a:endParaRPr>
+            </a:p>
+          </p:txBody>
+        </p:sp>
+        <p:sp>
+          <p:nvSpPr>
+            <p:cNvPr id="13" name="Frame 12">
+              <a:extLst>
+                <a:ext uri="{FF2B5EF4-FFF2-40B4-BE49-F238E27FC236}">
+                  <a16:creationId xmlns:a16="http://schemas.microsoft.com/office/drawing/2014/main" id="{60A06877-D8CF-4544-8709-1E36A67C64DC}"/>
+                </a:ext>
+              </a:extLst>
+            </p:cNvPr>
+            <p:cNvSpPr/>
+            <p:nvPr/>
+          </p:nvSpPr>
+          <p:spPr>
+            <a:xfrm>
+              <a:off x="8001012" y="4963506"/>
+              <a:ext cx="685801" cy="685800"/>
+            </a:xfrm>
+            <a:prstGeom prst="frame">
+              <a:avLst/>
+            </a:prstGeom>
+          </p:spPr>
+          <p:style>
+            <a:lnRef idx="2">
+              <a:schemeClr val="accent1">
+                <a:shade val="50000"/>
+              </a:schemeClr>
+            </a:lnRef>
+            <a:fillRef idx="1">
+              <a:schemeClr val="accent1"/>
+            </a:fillRef>
+            <a:effectRef idx="0">
+              <a:schemeClr val="accent1"/>
+            </a:effectRef>
+            <a:fontRef idx="minor">
+              <a:schemeClr val="lt1"/>
+            </a:fontRef>
+          </p:style>
+          <p:txBody>
+            <a:bodyPr rtlCol="0" anchor="ctr"/>
+            <a:lstStyle/>
+            <a:p>
+              <a:pPr algn="ctr"/>
+              <a:endParaRPr lang="en-US">
                 <a:solidFill>
                   <a:schemeClr val="tx1"/>
                 </a:solidFill>
-                <a:latin typeface="+mn-lt"/>
-                <a:ea typeface="+mn-ea"/>
-                <a:cs typeface="+mn-cs"/>
-              </a:defRPr>
-            </a:lvl9pPr>
-          </a:lstStyle>
-          <a:p>
-            <a:pPr marL="0" indent="0" algn="ctr" fontAlgn="auto">
-              <a:spcAft>
-                <a:spcPts val="0"/>
-              </a:spcAft>
-              <a:buNone/>
-            </a:pPr>
-            <a:endParaRPr lang="en-US" dirty="0"/>
-          </a:p>
-          <a:p>
-            <a:pPr marL="0" indent="0" algn="l" fontAlgn="auto">
-              <a:spcAft>
-                <a:spcPts val="0"/>
-              </a:spcAft>
-              <a:buNone/>
-            </a:pPr>
-            <a:r>
-              <a:rPr lang="en-US" i="1" dirty="0"/>
-              <a:t>  0      1     2     3      4      5      6      7</a:t>
-            </a:r>
-          </a:p>
-        </p:txBody>
-      </p:sp>
+              </a:endParaRPr>
+            </a:p>
+          </p:txBody>
+        </p:sp>
+        <p:sp>
+          <p:nvSpPr>
+            <p:cNvPr id="14" name="Rectangle 3">
+              <a:extLst>
+                <a:ext uri="{FF2B5EF4-FFF2-40B4-BE49-F238E27FC236}">
+                  <a16:creationId xmlns:a16="http://schemas.microsoft.com/office/drawing/2014/main" id="{0E5A8076-DD7C-5C4F-8A0B-8BF37F39908F}"/>
+                </a:ext>
+              </a:extLst>
+            </p:cNvPr>
+            <p:cNvSpPr txBox="1">
+              <a:spLocks noChangeArrowheads="1"/>
+            </p:cNvSpPr>
+            <p:nvPr>
+              <p:custDataLst>
+                <p:tags r:id="rId6"/>
+              </p:custDataLst>
+            </p:nvPr>
+          </p:nvSpPr>
+          <p:spPr>
+            <a:xfrm>
+              <a:off x="3200400" y="5192106"/>
+              <a:ext cx="5486406" cy="1143000"/>
+            </a:xfrm>
+            <a:prstGeom prst="rect">
+              <a:avLst/>
+            </a:prstGeom>
+          </p:spPr>
+          <p:txBody>
+            <a:bodyPr vert="horz">
+              <a:normAutofit/>
+            </a:bodyPr>
+            <a:lstStyle>
+              <a:lvl1pPr marL="274320" indent="-274320" algn="just" rtl="0" eaLnBrk="1" latinLnBrk="0" hangingPunct="1">
+                <a:spcBef>
+                  <a:spcPts val="600"/>
+                </a:spcBef>
+                <a:buClr>
+                  <a:schemeClr val="accent1"/>
+                </a:buClr>
+                <a:buSzPct val="76000"/>
+                <a:buFont typeface="Wingdings 3"/>
+                <a:buChar char=""/>
+                <a:defRPr kumimoji="0" sz="2600" kern="1200">
+                  <a:solidFill>
+                    <a:schemeClr val="tx1"/>
+                  </a:solidFill>
+                  <a:latin typeface="+mn-lt"/>
+                  <a:ea typeface="+mn-ea"/>
+                  <a:cs typeface="+mn-cs"/>
+                </a:defRPr>
+              </a:lvl1pPr>
+              <a:lvl2pPr marL="548640" indent="-274320" algn="just" rtl="0" eaLnBrk="1" latinLnBrk="0" hangingPunct="1">
+                <a:spcBef>
+                  <a:spcPts val="500"/>
+                </a:spcBef>
+                <a:buClr>
+                  <a:schemeClr val="accent2"/>
+                </a:buClr>
+                <a:buSzPct val="76000"/>
+                <a:buFont typeface="Wingdings 3"/>
+                <a:buChar char=""/>
+                <a:defRPr kumimoji="0" sz="2300" kern="1200">
+                  <a:solidFill>
+                    <a:schemeClr val="tx2"/>
+                  </a:solidFill>
+                  <a:latin typeface="+mn-lt"/>
+                  <a:ea typeface="+mn-ea"/>
+                  <a:cs typeface="+mn-cs"/>
+                </a:defRPr>
+              </a:lvl2pPr>
+              <a:lvl3pPr marL="822960" indent="-228600" algn="just" rtl="0" eaLnBrk="1" latinLnBrk="0" hangingPunct="1">
+                <a:spcBef>
+                  <a:spcPts val="500"/>
+                </a:spcBef>
+                <a:buClr>
+                  <a:schemeClr val="bg1">
+                    <a:shade val="50000"/>
+                  </a:schemeClr>
+                </a:buClr>
+                <a:buSzPct val="76000"/>
+                <a:buFont typeface="Wingdings 3"/>
+                <a:buChar char=""/>
+                <a:defRPr kumimoji="0" sz="2000" kern="1200">
+                  <a:solidFill>
+                    <a:schemeClr val="tx1"/>
+                  </a:solidFill>
+                  <a:latin typeface="+mn-lt"/>
+                  <a:ea typeface="+mn-ea"/>
+                  <a:cs typeface="+mn-cs"/>
+                </a:defRPr>
+              </a:lvl3pPr>
+              <a:lvl4pPr marL="1097280" indent="-228600" algn="just" rtl="0" eaLnBrk="1" latinLnBrk="0" hangingPunct="1">
+                <a:spcBef>
+                  <a:spcPts val="400"/>
+                </a:spcBef>
+                <a:buClr>
+                  <a:schemeClr val="accent2">
+                    <a:shade val="75000"/>
+                  </a:schemeClr>
+                </a:buClr>
+                <a:buSzPct val="70000"/>
+                <a:buFont typeface="Wingdings"/>
+                <a:buChar char=""/>
+                <a:defRPr kumimoji="0" sz="1800" kern="1200">
+                  <a:solidFill>
+                    <a:schemeClr val="tx1"/>
+                  </a:solidFill>
+                  <a:latin typeface="+mn-lt"/>
+                  <a:ea typeface="+mn-ea"/>
+                  <a:cs typeface="+mn-cs"/>
+                </a:defRPr>
+              </a:lvl4pPr>
+              <a:lvl5pPr marL="1371600" indent="-228600" algn="just" rtl="0" eaLnBrk="1" latinLnBrk="0" hangingPunct="1">
+                <a:spcBef>
+                  <a:spcPts val="300"/>
+                </a:spcBef>
+                <a:buClr>
+                  <a:schemeClr val="accent2"/>
+                </a:buClr>
+                <a:buSzPct val="70000"/>
+                <a:buFont typeface="Wingdings"/>
+                <a:buChar char=""/>
+                <a:defRPr kumimoji="0" sz="1600" kern="1200">
+                  <a:solidFill>
+                    <a:schemeClr val="tx1"/>
+                  </a:solidFill>
+                  <a:latin typeface="+mn-lt"/>
+                  <a:ea typeface="+mn-ea"/>
+                  <a:cs typeface="+mn-cs"/>
+                </a:defRPr>
+              </a:lvl5pPr>
+              <a:lvl6pPr marL="1645920" indent="-182880" algn="l" rtl="0" eaLnBrk="1" latinLnBrk="0" hangingPunct="1">
+                <a:spcBef>
+                  <a:spcPts val="300"/>
+                </a:spcBef>
+                <a:buClr>
+                  <a:srgbClr val="9FB8CD">
+                    <a:shade val="75000"/>
+                  </a:srgbClr>
+                </a:buClr>
+                <a:buSzPct val="75000"/>
+                <a:buFont typeface="Wingdings 3"/>
+                <a:buChar char=""/>
+                <a:defRPr kumimoji="0" lang="en-US" sz="1600" kern="1200" smtClean="0">
+                  <a:solidFill>
+                    <a:schemeClr val="tx1"/>
+                  </a:solidFill>
+                  <a:latin typeface="+mn-lt"/>
+                  <a:ea typeface="+mn-ea"/>
+                  <a:cs typeface="+mn-cs"/>
+                </a:defRPr>
+              </a:lvl6pPr>
+              <a:lvl7pPr marL="1828800" indent="-182880" algn="l" rtl="0" eaLnBrk="1" latinLnBrk="0" hangingPunct="1">
+                <a:spcBef>
+                  <a:spcPts val="300"/>
+                </a:spcBef>
+                <a:buClr>
+                  <a:srgbClr val="727CA3">
+                    <a:shade val="75000"/>
+                  </a:srgbClr>
+                </a:buClr>
+                <a:buSzPct val="75000"/>
+                <a:buFont typeface="Wingdings 3"/>
+                <a:buChar char=""/>
+                <a:defRPr kumimoji="0" lang="en-US" sz="1400" kern="1200" smtClean="0">
+                  <a:solidFill>
+                    <a:schemeClr val="tx1"/>
+                  </a:solidFill>
+                  <a:latin typeface="+mn-lt"/>
+                  <a:ea typeface="+mn-ea"/>
+                  <a:cs typeface="+mn-cs"/>
+                </a:defRPr>
+              </a:lvl7pPr>
+              <a:lvl8pPr marL="2011680" indent="-182880" algn="l" rtl="0" eaLnBrk="1" latinLnBrk="0" hangingPunct="1">
+                <a:spcBef>
+                  <a:spcPts val="300"/>
+                </a:spcBef>
+                <a:buClr>
+                  <a:prstClr val="white">
+                    <a:shade val="50000"/>
+                  </a:prstClr>
+                </a:buClr>
+                <a:buSzPct val="75000"/>
+                <a:buFont typeface="Wingdings 3"/>
+                <a:buChar char=""/>
+                <a:defRPr kumimoji="0" lang="en-US" sz="1400" kern="1200" smtClean="0">
+                  <a:solidFill>
+                    <a:schemeClr val="tx1"/>
+                  </a:solidFill>
+                  <a:latin typeface="+mn-lt"/>
+                  <a:ea typeface="+mn-ea"/>
+                  <a:cs typeface="+mn-cs"/>
+                </a:defRPr>
+              </a:lvl8pPr>
+              <a:lvl9pPr marL="2194560" indent="-182880" algn="l" rtl="0" eaLnBrk="1" latinLnBrk="0" hangingPunct="1">
+                <a:spcBef>
+                  <a:spcPts val="300"/>
+                </a:spcBef>
+                <a:buClr>
+                  <a:srgbClr val="9FB8CD"/>
+                </a:buClr>
+                <a:buSzPct val="75000"/>
+                <a:buFont typeface="Wingdings 3"/>
+                <a:buChar char=""/>
+                <a:defRPr kumimoji="0" lang="en-US" sz="1200" kern="1200" smtClean="0">
+                  <a:solidFill>
+                    <a:schemeClr val="tx1"/>
+                  </a:solidFill>
+                  <a:latin typeface="+mn-lt"/>
+                  <a:ea typeface="+mn-ea"/>
+                  <a:cs typeface="+mn-cs"/>
+                </a:defRPr>
+              </a:lvl9pPr>
+            </a:lstStyle>
+            <a:p>
+              <a:pPr marL="0" indent="0" algn="ctr" fontAlgn="auto">
+                <a:spcAft>
+                  <a:spcPts val="0"/>
+                </a:spcAft>
+                <a:buNone/>
+              </a:pPr>
+              <a:endParaRPr lang="en-US" dirty="0"/>
+            </a:p>
+            <a:p>
+              <a:pPr marL="0" indent="0" algn="l" fontAlgn="auto">
+                <a:spcAft>
+                  <a:spcPts val="0"/>
+                </a:spcAft>
+                <a:buNone/>
+              </a:pPr>
+              <a:r>
+                <a:rPr lang="en-US" i="1" dirty="0"/>
+                <a:t>  0      1     2     3      4      5      6      7</a:t>
+              </a:r>
+            </a:p>
+          </p:txBody>
+        </p:sp>
+      </p:grpSp>
       <p:sp>
         <p:nvSpPr>
           <p:cNvPr id="15" name="Rectangle 3">
@@ -15489,7 +15510,7 @@
           </p:cNvSpPr>
           <p:nvPr>
             <p:custDataLst>
-              <p:tags r:id="rId4"/>
+              <p:tags r:id="rId3"/>
             </p:custDataLst>
           </p:nvPr>
         </p:nvSpPr>
@@ -15726,7 +15747,7 @@
           </p:cNvSpPr>
           <p:nvPr>
             <p:custDataLst>
-              <p:tags r:id="rId5"/>
+              <p:tags r:id="rId4"/>
             </p:custDataLst>
           </p:nvPr>
         </p:nvSpPr>
@@ -15943,7 +15964,7 @@
           </p:cNvSpPr>
           <p:nvPr>
             <p:custDataLst>
-              <p:tags r:id="rId6"/>
+              <p:tags r:id="rId5"/>
             </p:custDataLst>
           </p:nvPr>
         </p:nvSpPr>

</xml_diff>